<commit_message>
Point docs and template guide to github.com/KimJaehee0725/research-slides
Co-Authored-By: Claude Opus 5.5 <noreply@anthropic.com>
Claude-Session: https://claude.ai/code/session_01CRYKz9L226Zc5z5G9HEjyc
</commit_message>
<xml_diff>
--- a/assets/research-slides-template.pptx
+++ b/assets/research-slides-template.pptx
@@ -5485,7 +5485,7 @@
           <a:p>
             <a:pPr lvl="1"/>
             <a:r>
-              <a:t>스킬이 없으면 GitHub의 research-slides repo를 받아 사용</a:t>
+              <a:t>스킬이 없으면 github.com/KimJaehee0725/research-slides 를 받아 사용</a:t>
             </a:r>
           </a:p>
           <a:p>
@@ -7277,7 +7277,7 @@
       </p:sp>
       <p:pic>
         <p:nvPicPr>
-          <p:cNvPr id="16" name="Picture 15" descr="tmp9nuh99h4.png"/>
+          <p:cNvPr id="16" name="Picture 15" descr="tmppveia5y0.png"/>
           <p:cNvPicPr>
             <a:picLocks noChangeAspect="1"/>
           </p:cNvPicPr>

</xml_diff>

<commit_message>
Noun-style titles and native PowerPoint equations
- Title rule: noun phrase, max 4 words, noun-form ending; build warns on violations
- Equations as OMML (LaTeX via pandoc): `math` shape and inline `$...$` in any text,
  wrapped in mc:AlternateContent with image/text fallback for non-Office viewers
- Docs, examples and template prompts updated

Co-Authored-By: Claude Opus 5.5 <noreply@anthropic.com>
Claude-Session: https://claude.ai/code/session_01CRYKz9L226Zc5z5G9HEjyc
</commit_message>
<xml_diff>
--- a/assets/research-slides-template.pptx
+++ b/assets/research-slides-template.pptx
@@ -1415,7 +1415,7 @@
           <a:p>
             <a:r>
               <a:rPr lang="ko-KR" dirty="0"/>
-              <a:t>슬라이드 제목: 한 장의 핵심 메시지</a:t>
+              <a:t>제목: 명사 위주 4단어 이내</a:t>
             </a:r>
           </a:p>
         </p:txBody>
@@ -2476,7 +2476,7 @@
           <a:p>
             <a:r>
               <a:rPr lang="ko-KR" dirty="0"/>
-              <a:t>슬라이드 제목: 한 장의 핵심 메시지</a:t>
+              <a:t>제목: 명사 위주 4단어 이내</a:t>
             </a:r>
           </a:p>
         </p:txBody>
@@ -2813,7 +2813,7 @@
           <a:p>
             <a:r>
               <a:rPr lang="ko-KR" dirty="0"/>
-              <a:t>슬라이드 제목: 한 장의 핵심 메시지</a:t>
+              <a:t>제목: 명사 위주 4단어 이내</a:t>
             </a:r>
           </a:p>
         </p:txBody>
@@ -3203,7 +3203,7 @@
           <a:p>
             <a:r>
               <a:rPr lang="ko-KR" dirty="0"/>
-              <a:t>슬라이드 제목: 한 장의 핵심 메시지</a:t>
+              <a:t>제목: 명사 위주 4단어 이내</a:t>
             </a:r>
           </a:p>
         </p:txBody>
@@ -3654,7 +3654,7 @@
           <a:p>
             <a:r>
               <a:rPr lang="ko-KR" dirty="0"/>
-              <a:t>슬라이드 제목: 한 장의 핵심 메시지</a:t>
+              <a:t>제목: 명사 위주 4단어 이내</a:t>
             </a:r>
           </a:p>
         </p:txBody>
@@ -3991,7 +3991,7 @@
           <a:p>
             <a:r>
               <a:rPr lang="ko-KR" dirty="0"/>
-              <a:t>슬라이드 제목: 한 장의 핵심 메시지</a:t>
+              <a:t>제목: 명사 위주 4단어 이내</a:t>
             </a:r>
           </a:p>
         </p:txBody>
@@ -4511,7 +4511,7 @@
           <a:p>
             <a:r>
               <a:rPr lang="ko-KR" dirty="0"/>
-              <a:t>슬라이드 제목: 한 장의 핵심 메시지</a:t>
+              <a:t>제목: 명사 위주 4단어 이내</a:t>
             </a:r>
           </a:p>
         </p:txBody>
@@ -4795,7 +4795,7 @@
           <a:p>
             <a:r>
               <a:rPr lang="ko-KR" dirty="0"/>
-              <a:t>슬라이드 제목: 한 장의 핵심 메시지</a:t>
+              <a:t>제목: 명사 위주 4단어 이내</a:t>
             </a:r>
           </a:p>
         </p:txBody>
@@ -5571,7 +5571,7 @@
           <a:p>
             <a:pPr/>
             <a:r>
-              <a:t>두 그림을 나란히 비교할 때</a:t>
+              <a:t>그림 2개 비교</a:t>
             </a:r>
           </a:p>
         </p:txBody>
@@ -5731,7 +5731,7 @@
           <a:p>
             <a:pPr/>
             <a:r>
-              <a:t>그림과 해설을 함께 둘 때</a:t>
+              <a:t>그림과 해설</a:t>
             </a:r>
           </a:p>
         </p:txBody>
@@ -5909,7 +5909,7 @@
           <a:p>
             <a:pPr/>
             <a:r>
-              <a:t>표처럼 세로로 큰 개체를 넣을 때</a:t>
+              <a:t>표·차트 배치</a:t>
             </a:r>
           </a:p>
         </p:txBody>
@@ -6519,7 +6519,7 @@
           <a:p>
             <a:pPr/>
             <a:r>
-              <a:t>두 관점을 나란히 정리할 때</a:t>
+              <a:t>2단 비교 정리</a:t>
             </a:r>
           </a:p>
         </p:txBody>
@@ -6727,7 +6727,7 @@
           <a:p>
             <a:pPr/>
             <a:r>
-              <a:t>도형으로 구조를 설명할 때</a:t>
+              <a:t>도형·수식 구성</a:t>
             </a:r>
           </a:p>
         </p:txBody>
@@ -7275,30 +7275,167 @@
           </a:p>
         </p:txBody>
       </p:sp>
-      <p:pic>
-        <p:nvPicPr>
-          <p:cNvPr id="16" name="Picture 15" descr="tmppveia5y0.png"/>
-          <p:cNvPicPr>
-            <a:picLocks noChangeAspect="1"/>
-          </p:cNvPicPr>
-          <p:nvPr/>
-        </p:nvPicPr>
-        <p:blipFill>
-          <a:blip r:embed="rId2"/>
-          <a:stretch>
-            <a:fillRect/>
-          </a:stretch>
-        </p:blipFill>
-        <p:spPr>
-          <a:xfrm>
-            <a:off x="13711428" y="5187893"/>
-            <a:ext cx="3552444" cy="640904"/>
-          </a:xfrm>
-          <a:prstGeom prst="rect">
-            <a:avLst/>
-          </a:prstGeom>
-        </p:spPr>
-      </p:pic>
+      <mc:AlternateContent xmlns:mc="http://schemas.openxmlformats.org/markup-compatibility/2006">
+        <mc:Choice xmlns:a14="http://schemas.microsoft.com/office/drawing/2010/main" Requires="a14">
+          <p:sp>
+            <p:nvSpPr>
+              <p:cNvPr id="16" name="TextBox 15"/>
+              <p:cNvSpPr txBox="1"/>
+              <p:nvPr/>
+            </p:nvSpPr>
+            <p:spPr>
+              <a:xfrm>
+                <a:off x="13711428" y="4762195"/>
+                <a:ext cx="3552444" cy="1492300"/>
+              </a:xfrm>
+              <a:prstGeom prst="rect">
+                <a:avLst/>
+              </a:prstGeom>
+              <a:noFill/>
+            </p:spPr>
+            <p:txBody>
+              <a:bodyPr wrap="square" anchor="ctr">
+                <a:spAutoFit/>
+              </a:bodyPr>
+              <a:lstStyle/>
+              <a:p>
+                <a14:m xmlns:m="http://schemas.openxmlformats.org/officeDocument/2006/math">
+                  <m:oMathPara>
+                    <m:oMathParaPr>
+                      <m:jc m:val="centerGroup"/>
+                    </m:oMathParaPr>
+                    <m:oMath>
+                      <m:sSub>
+                        <m:e>
+                          <m:r>
+                            <a:rPr lang="en-US" i="1" b="0" sz="3600">
+                              <a:latin typeface="Cambria Math"/>
+                              <a:cs typeface="Cambria Math"/>
+                            </a:rPr>
+                            <m:t>r</m:t>
+                          </m:r>
+                        </m:e>
+                        <m:sub>
+                          <m:r>
+                            <a:rPr lang="en-US" i="1" b="0" sz="3600">
+                              <a:latin typeface="Cambria Math"/>
+                              <a:cs typeface="Cambria Math"/>
+                            </a:rPr>
+                            <m:t>t</m:t>
+                          </m:r>
+                        </m:sub>
+                      </m:sSub>
+                      <m:r>
+                        <m:rPr>
+                          <m:sty m:val="p"/>
+                        </m:rPr>
+                        <a:rPr lang="en-US" i="0" b="0" sz="3600">
+                          <a:latin typeface="Cambria Math"/>
+                          <a:cs typeface="Cambria Math"/>
+                        </a:rPr>
+                        <m:t>=</m:t>
+                      </m:r>
+                      <m:sSub>
+                        <m:e>
+                          <m:r>
+                            <a:rPr lang="en-US" i="1" b="0" sz="3600">
+                              <a:latin typeface="Cambria Math"/>
+                              <a:cs typeface="Cambria Math"/>
+                            </a:rPr>
+                            <m:t>b</m:t>
+                          </m:r>
+                        </m:e>
+                        <m:sub>
+                          <m:r>
+                            <a:rPr lang="en-US" i="1" b="0" sz="3600">
+                              <a:latin typeface="Cambria Math"/>
+                              <a:cs typeface="Cambria Math"/>
+                            </a:rPr>
+                            <m:t>t</m:t>
+                          </m:r>
+                        </m:sub>
+                      </m:sSub>
+                      <m:r>
+                        <m:rPr>
+                          <m:sty m:val="p"/>
+                        </m:rPr>
+                        <a:rPr lang="en-US" i="0" b="0" sz="3600">
+                          <a:latin typeface="Cambria Math"/>
+                          <a:cs typeface="Cambria Math"/>
+                        </a:rPr>
+                        <m:t>−</m:t>
+                      </m:r>
+                      <m:sSub>
+                        <m:e>
+                          <m:r>
+                            <a:rPr lang="en-US" i="1" b="0" sz="3600">
+                              <a:latin typeface="Cambria Math"/>
+                              <a:cs typeface="Cambria Math"/>
+                            </a:rPr>
+                            <m:t>b</m:t>
+                          </m:r>
+                        </m:e>
+                        <m:sub>
+                          <m:r>
+                            <a:rPr lang="en-US" i="1" b="0" sz="3600">
+                              <a:latin typeface="Cambria Math"/>
+                              <a:cs typeface="Cambria Math"/>
+                            </a:rPr>
+                            <m:t>t</m:t>
+                          </m:r>
+                          <m:r>
+                            <m:rPr>
+                              <m:sty m:val="p"/>
+                            </m:rPr>
+                            <a:rPr lang="en-US" i="0" b="0" sz="3600">
+                              <a:latin typeface="Cambria Math"/>
+                              <a:cs typeface="Cambria Math"/>
+                            </a:rPr>
+                            <m:t>−</m:t>
+                          </m:r>
+                          <m:r>
+                            <a:rPr lang="en-US" i="1" b="0" sz="3600">
+                              <a:latin typeface="Cambria Math"/>
+                              <a:cs typeface="Cambria Math"/>
+                            </a:rPr>
+                            <m:t>1</m:t>
+                          </m:r>
+                        </m:sub>
+                      </m:sSub>
+                    </m:oMath>
+                  </m:oMathPara>
+                </a14:m>
+              </a:p>
+            </p:txBody>
+          </p:sp>
+        </mc:Choice>
+        <mc:Fallback>
+          <p:pic>
+            <p:nvPicPr>
+              <p:cNvPr id="17" name="Picture 16" descr="tmp4w5o6rat.png"/>
+              <p:cNvPicPr>
+                <a:picLocks noChangeAspect="1"/>
+              </p:cNvPicPr>
+              <p:nvPr/>
+            </p:nvPicPr>
+            <p:blipFill>
+              <a:blip r:embed="rId2"/>
+              <a:stretch>
+                <a:fillRect/>
+              </a:stretch>
+            </p:blipFill>
+            <p:spPr>
+              <a:xfrm>
+                <a:off x="14018514" y="5250789"/>
+                <a:ext cx="2938272" cy="515112"/>
+              </a:xfrm>
+              <a:prstGeom prst="rect">
+                <a:avLst/>
+              </a:prstGeom>
+            </p:spPr>
+          </p:pic>
+        </mc:Fallback>
+      </mc:AlternateContent>
     </p:spTree>
   </p:cSld>
   <p:clrMapOvr>
@@ -7356,7 +7493,7 @@
           <a:p>
             <a:pPr/>
             <a:r>
-              <a:t>자유 구성: 네이티브 차트 예시</a:t>
+              <a:t>네이티브 차트</a:t>
             </a:r>
           </a:p>
         </p:txBody>
@@ -9519,64 +9656,184 @@
           </a:p>
         </p:txBody>
       </p:sp>
-      <p:sp>
-        <p:nvSpPr>
-          <p:cNvPr id="3" name="Text Placeholder 2"/>
-          <p:cNvSpPr>
-            <a:spLocks noGrp="1"/>
-          </p:cNvSpPr>
-          <p:nvPr>
-            <p:ph type="body" idx="1"/>
-          </p:nvPr>
-        </p:nvSpPr>
-        <p:spPr/>
-        <p:txBody>
-          <a:bodyPr/>
-          <a:lstStyle/>
-          <a:p>
-            <a:pPr/>
-            <a:r>
-              <a:t>한 장에 핵심 메시지 하나. 제목만 읽어도 주제가 보이게 작성</a:t>
-            </a:r>
-          </a:p>
-          <a:p>
-            <a:pPr/>
-            <a:r>
-              <a:t>밴드 1단은 주장, 2단은 근거·수치. 32pt 기준 한 줄 40자, 3~4줄</a:t>
-            </a:r>
-          </a:p>
-          <a:p>
-            <a:pPr lvl="1"/>
-            <a:r>
-              <a:t>종결은 명사형 (~함 / ~임 / ~확인)</a:t>
-            </a:r>
-          </a:p>
-          <a:p>
-            <a:pPr/>
-            <a:r>
-              <a:t>그림은 논문 캡쳐를 그대로 쓰고, 중요한 영역만 강조 틀로 표시</a:t>
-            </a:r>
-          </a:p>
-          <a:p>
-            <a:pPr/>
-            <a:r>
-              <a:t>출처는 하단 바 오른쪽 source 칸에 (Author et al., Venue Year)</a:t>
-            </a:r>
-          </a:p>
-          <a:p>
-            <a:pPr/>
-            <a:r>
-              <a:t>내레이션 대본은 발표자 노트에 작성: 슬라이드당 30~60초, 합니다체 구어</a:t>
-            </a:r>
-          </a:p>
-          <a:p>
-            <a:pPr lvl="1"/>
-            <a:r>
-              <a:t>슬라이드 문장을 그대로 읽지 않고, 왜 중요한지와 다음 슬라이드로의 연결을 말함</a:t>
-            </a:r>
-          </a:p>
-        </p:txBody>
-      </p:sp>
+      <mc:AlternateContent xmlns:mc="http://schemas.openxmlformats.org/markup-compatibility/2006">
+        <mc:Choice xmlns:a14="http://schemas.microsoft.com/office/drawing/2010/main" Requires="a14">
+          <p:sp>
+            <p:nvSpPr>
+              <p:cNvPr id="3" name="Text Placeholder 2"/>
+              <p:cNvSpPr>
+                <a:spLocks noGrp="1"/>
+              </p:cNvSpPr>
+              <p:nvPr>
+                <p:ph type="body" idx="1"/>
+              </p:nvPr>
+            </p:nvSpPr>
+            <p:spPr/>
+            <p:txBody>
+              <a:bodyPr/>
+              <a:lstStyle/>
+              <a:p>
+                <a:pPr/>
+                <a:r>
+                  <a:t>제목은 명사 위주 4단어 이내, 명사형으로 끝맺음 (예: RLHF vs SFT, 실험 결과, Training Dynamics)</a:t>
+                </a:r>
+              </a:p>
+              <a:p>
+                <a:pPr/>
+                <a:r>
+                  <a:t>한 장에 핵심 메시지 하나: 주장은 제목이 아니라 밴드 1단에, 근거·수치는 2단에 (32pt 기준 한 줄 40자, 3~4줄)</a:t>
+                </a:r>
+              </a:p>
+              <a:p>
+                <a:pPr lvl="1"/>
+                <a:r>
+                  <a:t>종결은 명사형 (~함 / ~임 / ~확인)</a:t>
+                </a:r>
+              </a:p>
+              <a:p>
+                <a:pPr/>
+                <a:r>
+                  <a:t>그림은 논문 캡쳐를 그대로 쓰고, 중요한 영역만 강조 틀로 표시</a:t>
+                </a:r>
+              </a:p>
+              <a:p>
+                <a:pPr/>
+                <a:r>
+                  <a:t>수식은 PowerPoint 수식으로: 본문 안은 </a:t>
+                </a:r>
+                <a14:m xmlns:m="http://schemas.openxmlformats.org/officeDocument/2006/math">
+                  <m:oMath>
+                    <m:r>
+                      <m:rPr>
+                        <m:sty m:val="p"/>
+                      </m:rPr>
+                      <a:rPr lang="en-US" i="0" b="0">
+                        <a:latin typeface="Cambria Math"/>
+                        <a:cs typeface="Cambria Math"/>
+                      </a:rPr>
+                      <m:t>.</m:t>
+                    </m:r>
+                    <m:r>
+                      <m:rPr>
+                        <m:sty m:val="p"/>
+                      </m:rPr>
+                      <a:rPr lang="en-US" i="0" b="0">
+                        <a:latin typeface="Cambria Math"/>
+                        <a:cs typeface="Cambria Math"/>
+                      </a:rPr>
+                      <m:t>.</m:t>
+                    </m:r>
+                    <m:r>
+                      <m:rPr>
+                        <m:sty m:val="p"/>
+                      </m:rPr>
+                      <a:rPr lang="en-US" i="0" b="0">
+                        <a:latin typeface="Cambria Math"/>
+                        <a:cs typeface="Cambria Math"/>
+                      </a:rPr>
+                      <m:t>.</m:t>
+                    </m:r>
+                  </m:oMath>
+                </a14:m>
+                <a:r>
+                  <a:t>, 단독 수식은 math 컴포넌트 (LaTeX 입력)</a:t>
+                </a:r>
+              </a:p>
+              <a:p>
+                <a:pPr/>
+                <a:r>
+                  <a:t>출처는 하단 바 오른쪽 source 칸에 (Author et al., Venue Year)</a:t>
+                </a:r>
+              </a:p>
+              <a:p>
+                <a:pPr/>
+                <a:r>
+                  <a:t>내레이션 대본은 발표자 노트에 작성: 슬라이드당 30~60초, 합니다체 구어</a:t>
+                </a:r>
+              </a:p>
+              <a:p>
+                <a:pPr lvl="1"/>
+                <a:r>
+                  <a:t>슬라이드 문장을 그대로 읽지 않고, 왜 중요한지와 다음 슬라이드로의 연결을 말함</a:t>
+                </a:r>
+              </a:p>
+            </p:txBody>
+          </p:sp>
+        </mc:Choice>
+        <mc:Fallback>
+          <p:sp>
+            <p:nvSpPr>
+              <p:cNvPr id="3" name="Text Placeholder 2"/>
+              <p:cNvSpPr>
+                <a:spLocks noGrp="1"/>
+              </p:cNvSpPr>
+              <p:nvPr>
+                <p:ph type="body" idx="1"/>
+              </p:nvPr>
+            </p:nvSpPr>
+            <p:spPr/>
+            <p:txBody>
+              <a:bodyPr/>
+              <a:lstStyle/>
+              <a:p>
+                <a:pPr/>
+                <a:r>
+                  <a:t>제목은 명사 위주 4단어 이내, 명사형으로 끝맺음 (예: RLHF vs SFT, 실험 결과, Training Dynamics)</a:t>
+                </a:r>
+              </a:p>
+              <a:p>
+                <a:pPr/>
+                <a:r>
+                  <a:t>한 장에 핵심 메시지 하나: 주장은 제목이 아니라 밴드 1단에, 근거·수치는 2단에 (32pt 기준 한 줄 40자, 3~4줄)</a:t>
+                </a:r>
+              </a:p>
+              <a:p>
+                <a:pPr lvl="1"/>
+                <a:r>
+                  <a:t>종결은 명사형 (~함 / ~임 / ~확인)</a:t>
+                </a:r>
+              </a:p>
+              <a:p>
+                <a:pPr/>
+                <a:r>
+                  <a:t>그림은 논문 캡쳐를 그대로 쓰고, 중요한 영역만 강조 틀로 표시</a:t>
+                </a:r>
+              </a:p>
+              <a:p>
+                <a:pPr/>
+                <a:r>
+                  <a:t>수식은 PowerPoint 수식으로: 본문 안은 </a:t>
+                </a:r>
+                <a:r>
+                  <a:rPr lang="en-US"/>
+                  <a:t>...</a:t>
+                </a:r>
+                <a:r>
+                  <a:t>, 단독 수식은 math 컴포넌트 (LaTeX 입력)</a:t>
+                </a:r>
+              </a:p>
+              <a:p>
+                <a:pPr/>
+                <a:r>
+                  <a:t>출처는 하단 바 오른쪽 source 칸에 (Author et al., Venue Year)</a:t>
+                </a:r>
+              </a:p>
+              <a:p>
+                <a:pPr/>
+                <a:r>
+                  <a:t>내레이션 대본은 발표자 노트에 작성: 슬라이드당 30~60초, 합니다체 구어</a:t>
+                </a:r>
+              </a:p>
+              <a:p>
+                <a:pPr lvl="1"/>
+                <a:r>
+                  <a:t>슬라이드 문장을 그대로 읽지 않고, 왜 중요한지와 다음 슬라이드로의 연결을 말함</a:t>
+                </a:r>
+              </a:p>
+            </p:txBody>
+          </p:sp>
+        </mc:Fallback>
+      </mc:AlternateContent>
     </p:spTree>
   </p:cSld>
   <p:clrMapOvr>
@@ -9908,7 +10165,7 @@
           <a:p>
             <a:pPr/>
             <a:r>
-              <a:t>그림 한 장을 크게 보여줄 때</a:t>
+              <a:t>그림 1개 전면 배치</a:t>
             </a:r>
           </a:p>
         </p:txBody>

</xml_diff>

<commit_message>
No middle dots or long dashes; default line spacing 1.5
- Build warns on ·, ㆍ, —, –, ― in slide text (commas, colons, '/', '-' instead)
- Footer uses '|'; third-level bullet is •
- Line spacing 1.5 for bands, explain, cards and text boxes; per-role
  `line_spacing` override only when space is short
- render_check reads actual line spacing for overflow estimates

Co-Authored-By: Claude Opus 5.5 <noreply@anthropic.com>
Claude-Session: https://claude.ai/code/session_01CRYKz9L226Zc5z5G9HEjyc
</commit_message>
<xml_diff>
--- a/assets/research-slides-template.pptx
+++ b/assets/research-slides-template.pptx
@@ -1197,7 +1197,7 @@
           <a:lstStyle>
             <a:lvl1pPr marL="0" indent="0" algn="ctr">
               <a:lnSpc>
-                <a:spcPct val="120000"/>
+                <a:spcPct val="150000"/>
               </a:lnSpc>
               <a:spcBef>
                 <a:spcPts val="0"/>
@@ -1253,7 +1253,7 @@
           <a:lstStyle>
             <a:lvl1pPr marL="0" indent="0" algn="ctr">
               <a:lnSpc>
-                <a:spcPct val="130000"/>
+                <a:spcPct val="150000"/>
               </a:lnSpc>
               <a:spcBef>
                 <a:spcPts val="0"/>
@@ -1552,7 +1552,7 @@
           <a:lstStyle>
             <a:lvl1pPr marL="0" indent="0" algn="ctr">
               <a:lnSpc>
-                <a:spcPct val="130000"/>
+                <a:spcPct val="150000"/>
               </a:lnSpc>
               <a:spcBef>
                 <a:spcPts val="0"/>
@@ -1855,7 +1855,7 @@
           <a:p>
             <a:r>
               <a:rPr lang="ko-KR" dirty="0"/>
-              <a:t>Papers You Should Read · 2026 Q3</a:t>
+              <a:t>Papers You Should Read | 2026 Q3</a:t>
             </a:r>
           </a:p>
         </p:txBody>
@@ -2026,7 +2026,7 @@
                 <a:ea typeface="NanumSquareOTF"/>
                 <a:cs typeface="NanumSquareOTF"/>
               </a:rPr>
-              <a:t>숨김 가이드 · 발표에 나오지 않음</a:t>
+              <a:t>숨김 가이드: 발표에 나오지 않음</a:t>
             </a:r>
           </a:p>
         </p:txBody>
@@ -2081,10 +2081,10 @@
           <a:lstStyle>
             <a:lvl1pPr marL="502920" indent="-502920" algn="l">
               <a:lnSpc>
-                <a:spcPct val="120000"/>
+                <a:spcPct val="150000"/>
               </a:lnSpc>
               <a:spcBef>
-                <a:spcPts val="600"/>
+                <a:spcPts val="0"/>
               </a:spcBef>
               <a:spcAft>
                 <a:spcPts val="0"/>
@@ -2106,10 +2106,10 @@
             </a:lvl1pPr>
             <a:lvl2pPr marL="1005840" indent="-457200" algn="l">
               <a:lnSpc>
-                <a:spcPct val="120000"/>
+                <a:spcPct val="150000"/>
               </a:lnSpc>
               <a:spcBef>
-                <a:spcPts val="600"/>
+                <a:spcPts val="0"/>
               </a:spcBef>
               <a:spcAft>
                 <a:spcPts val="0"/>
@@ -2134,10 +2134,10 @@
             </a:lvl2pPr>
             <a:lvl3pPr marL="1463040" indent="-365760" algn="l">
               <a:lnSpc>
-                <a:spcPct val="120000"/>
+                <a:spcPct val="150000"/>
               </a:lnSpc>
               <a:spcBef>
-                <a:spcPts val="600"/>
+                <a:spcPts val="0"/>
               </a:spcBef>
               <a:spcAft>
                 <a:spcPts val="0"/>
@@ -2147,7 +2147,7 @@
               </a:buClr>
               <a:buSzPct val="90000"/>
               <a:buFont typeface="Arial" pitchFamily="2" charset="2"/>
-              <a:buChar char="–"/>
+              <a:buChar char="•"/>
               <a:defRPr lang="ko-KR" sz="1900" kern="0">
                 <a:solidFill>
                   <a:schemeClr val="tx1">
@@ -2582,7 +2582,7 @@
           <a:p>
             <a:r>
               <a:rPr lang="ko-KR" dirty="0"/>
-              <a:t>그림 삽입: 논문 figure·표 캡쳐 (비율 유지, 잘라내지 않음)</a:t>
+              <a:t>그림 삽입: 논문 figure, 표 캡쳐 (비율 유지, 잘라내지 않음)</a:t>
             </a:r>
           </a:p>
         </p:txBody>
@@ -2613,16 +2613,16 @@
           </a:solidFill>
         </p:spPr>
         <p:txBody>
-          <a:bodyPr wrap="square" lIns="365760" tIns="137160" rIns="365760" bIns="137160" anchor="ctr" rtlCol="0">
+          <a:bodyPr wrap="square" lIns="365760" tIns="91440" rIns="365760" bIns="91440" anchor="ctr" rtlCol="0">
             <a:normAutofit/>
           </a:bodyPr>
           <a:lstStyle>
             <a:lvl1pPr marL="502920" indent="-502920" algn="l">
               <a:lnSpc>
-                <a:spcPct val="125000"/>
+                <a:spcPct val="150000"/>
               </a:lnSpc>
               <a:spcBef>
-                <a:spcPts val="400"/>
+                <a:spcPts val="0"/>
               </a:spcBef>
               <a:spcAft>
                 <a:spcPts val="0"/>
@@ -2644,10 +2644,10 @@
             </a:lvl1pPr>
             <a:lvl2pPr marL="1005840" indent="-457200" algn="l">
               <a:lnSpc>
-                <a:spcPct val="125000"/>
+                <a:spcPct val="150000"/>
               </a:lnSpc>
               <a:spcBef>
-                <a:spcPts val="400"/>
+                <a:spcPts val="0"/>
               </a:spcBef>
               <a:spcAft>
                 <a:spcPts val="0"/>
@@ -2672,10 +2672,10 @@
             </a:lvl2pPr>
             <a:lvl3pPr marL="1463040" indent="-365760" algn="l">
               <a:lnSpc>
-                <a:spcPct val="125000"/>
+                <a:spcPct val="150000"/>
               </a:lnSpc>
               <a:spcBef>
-                <a:spcPts val="400"/>
+                <a:spcPts val="0"/>
               </a:spcBef>
               <a:spcAft>
                 <a:spcPts val="0"/>
@@ -2685,7 +2685,7 @@
               </a:buClr>
               <a:buSzPct val="90000"/>
               <a:buFont typeface="Arial" pitchFamily="2" charset="2"/>
-              <a:buChar char="–"/>
+              <a:buChar char="•"/>
               <a:defRPr lang="ko-KR" sz="2400" kern="0">
                 <a:solidFill>
                   <a:schemeClr val="tx1">
@@ -2919,7 +2919,7 @@
           <a:p>
             <a:r>
               <a:rPr lang="ko-KR" dirty="0"/>
-              <a:t>그림 삽입: 논문 figure·표 캡쳐 (비율 유지, 잘라내지 않음)</a:t>
+              <a:t>그림 삽입: 논문 figure, 표 캡쳐 (비율 유지, 잘라내지 않음)</a:t>
             </a:r>
           </a:p>
         </p:txBody>
@@ -2972,7 +2972,7 @@
           <a:p>
             <a:r>
               <a:rPr lang="ko-KR" dirty="0"/>
-              <a:t>그림 삽입: 논문 figure·표 캡쳐 (비율 유지, 잘라내지 않음)</a:t>
+              <a:t>그림 삽입: 논문 figure, 표 캡쳐 (비율 유지, 잘라내지 않음)</a:t>
             </a:r>
           </a:p>
         </p:txBody>
@@ -3003,16 +3003,16 @@
           </a:solidFill>
         </p:spPr>
         <p:txBody>
-          <a:bodyPr wrap="square" lIns="365760" tIns="137160" rIns="365760" bIns="137160" anchor="ctr" rtlCol="0">
+          <a:bodyPr wrap="square" lIns="365760" tIns="91440" rIns="365760" bIns="91440" anchor="ctr" rtlCol="0">
             <a:normAutofit/>
           </a:bodyPr>
           <a:lstStyle>
             <a:lvl1pPr marL="502920" indent="-502920" algn="l">
               <a:lnSpc>
-                <a:spcPct val="125000"/>
+                <a:spcPct val="150000"/>
               </a:lnSpc>
               <a:spcBef>
-                <a:spcPts val="400"/>
+                <a:spcPts val="0"/>
               </a:spcBef>
               <a:spcAft>
                 <a:spcPts val="0"/>
@@ -3034,10 +3034,10 @@
             </a:lvl1pPr>
             <a:lvl2pPr marL="1005840" indent="-457200" algn="l">
               <a:lnSpc>
-                <a:spcPct val="125000"/>
+                <a:spcPct val="150000"/>
               </a:lnSpc>
               <a:spcBef>
-                <a:spcPts val="400"/>
+                <a:spcPts val="0"/>
               </a:spcBef>
               <a:spcAft>
                 <a:spcPts val="0"/>
@@ -3062,10 +3062,10 @@
             </a:lvl2pPr>
             <a:lvl3pPr marL="1463040" indent="-365760" algn="l">
               <a:lnSpc>
-                <a:spcPct val="125000"/>
+                <a:spcPct val="150000"/>
               </a:lnSpc>
               <a:spcBef>
-                <a:spcPts val="400"/>
+                <a:spcPts val="0"/>
               </a:spcBef>
               <a:spcAft>
                 <a:spcPts val="0"/>
@@ -3075,7 +3075,7 @@
               </a:buClr>
               <a:buSzPct val="90000"/>
               <a:buFont typeface="Arial" pitchFamily="2" charset="2"/>
-              <a:buChar char="–"/>
+              <a:buChar char="•"/>
               <a:defRPr lang="ko-KR" sz="2400" kern="0">
                 <a:solidFill>
                   <a:schemeClr val="tx1">
@@ -3309,7 +3309,7 @@
           <a:p>
             <a:r>
               <a:rPr lang="ko-KR" dirty="0"/>
-              <a:t>그림 삽입: 논문 figure·표 캡쳐 (비율 유지, 잘라내지 않음)</a:t>
+              <a:t>그림 삽입: 논문 figure, 표 캡쳐 (비율 유지, 잘라내지 않음)</a:t>
             </a:r>
           </a:p>
         </p:txBody>
@@ -3340,10 +3340,10 @@
           <a:lstStyle>
             <a:lvl1pPr marL="502920" indent="-502920" algn="l">
               <a:lnSpc>
-                <a:spcPct val="120000"/>
+                <a:spcPct val="150000"/>
               </a:lnSpc>
               <a:spcBef>
-                <a:spcPts val="400"/>
+                <a:spcPts val="0"/>
               </a:spcBef>
               <a:spcAft>
                 <a:spcPts val="0"/>
@@ -3365,10 +3365,10 @@
             </a:lvl1pPr>
             <a:lvl2pPr marL="1005840" indent="-457200" algn="l">
               <a:lnSpc>
-                <a:spcPct val="120000"/>
+                <a:spcPct val="150000"/>
               </a:lnSpc>
               <a:spcBef>
-                <a:spcPts val="400"/>
+                <a:spcPts val="0"/>
               </a:spcBef>
               <a:spcAft>
                 <a:spcPts val="0"/>
@@ -3393,10 +3393,10 @@
             </a:lvl2pPr>
             <a:lvl3pPr marL="1463040" indent="-365760" algn="l">
               <a:lnSpc>
-                <a:spcPct val="120000"/>
+                <a:spcPct val="150000"/>
               </a:lnSpc>
               <a:spcBef>
-                <a:spcPts val="400"/>
+                <a:spcPts val="0"/>
               </a:spcBef>
               <a:spcAft>
                 <a:spcPts val="0"/>
@@ -3406,7 +3406,7 @@
               </a:buClr>
               <a:buSzPct val="90000"/>
               <a:buFont typeface="Arial" pitchFamily="2" charset="2"/>
-              <a:buChar char="–"/>
+              <a:buChar char="•"/>
               <a:defRPr lang="ko-KR" sz="2200" kern="0">
                 <a:solidFill>
                   <a:schemeClr val="tx1">
@@ -3454,16 +3454,16 @@
           </a:solidFill>
         </p:spPr>
         <p:txBody>
-          <a:bodyPr wrap="square" lIns="365760" tIns="137160" rIns="365760" bIns="137160" anchor="ctr" rtlCol="0">
+          <a:bodyPr wrap="square" lIns="365760" tIns="91440" rIns="365760" bIns="91440" anchor="ctr" rtlCol="0">
             <a:normAutofit/>
           </a:bodyPr>
           <a:lstStyle>
             <a:lvl1pPr marL="502920" indent="-502920" algn="l">
               <a:lnSpc>
-                <a:spcPct val="125000"/>
+                <a:spcPct val="150000"/>
               </a:lnSpc>
               <a:spcBef>
-                <a:spcPts val="400"/>
+                <a:spcPts val="0"/>
               </a:spcBef>
               <a:spcAft>
                 <a:spcPts val="0"/>
@@ -3485,10 +3485,10 @@
             </a:lvl1pPr>
             <a:lvl2pPr marL="1005840" indent="-457200" algn="l">
               <a:lnSpc>
-                <a:spcPct val="125000"/>
+                <a:spcPct val="150000"/>
               </a:lnSpc>
               <a:spcBef>
-                <a:spcPts val="400"/>
+                <a:spcPts val="0"/>
               </a:spcBef>
               <a:spcAft>
                 <a:spcPts val="0"/>
@@ -3513,10 +3513,10 @@
             </a:lvl2pPr>
             <a:lvl3pPr marL="1463040" indent="-365760" algn="l">
               <a:lnSpc>
-                <a:spcPct val="125000"/>
+                <a:spcPct val="150000"/>
               </a:lnSpc>
               <a:spcBef>
-                <a:spcPts val="400"/>
+                <a:spcPts val="0"/>
               </a:spcBef>
               <a:spcAft>
                 <a:spcPts val="0"/>
@@ -3526,7 +3526,7 @@
               </a:buClr>
               <a:buSzPct val="90000"/>
               <a:buFont typeface="Arial" pitchFamily="2" charset="2"/>
-              <a:buChar char="–"/>
+              <a:buChar char="•"/>
               <a:defRPr lang="ko-KR" sz="2400" kern="0">
                 <a:solidFill>
                   <a:schemeClr val="tx1">
@@ -3738,16 +3738,16 @@
           </a:solidFill>
         </p:spPr>
         <p:txBody>
-          <a:bodyPr wrap="square" lIns="365760" tIns="137160" rIns="365760" bIns="137160" anchor="ctr" rtlCol="0">
+          <a:bodyPr wrap="square" lIns="365760" tIns="91440" rIns="365760" bIns="91440" anchor="ctr" rtlCol="0">
             <a:normAutofit/>
           </a:bodyPr>
           <a:lstStyle>
             <a:lvl1pPr marL="502920" indent="-502920" algn="l">
               <a:lnSpc>
-                <a:spcPct val="125000"/>
+                <a:spcPct val="150000"/>
               </a:lnSpc>
               <a:spcBef>
-                <a:spcPts val="400"/>
+                <a:spcPts val="0"/>
               </a:spcBef>
               <a:spcAft>
                 <a:spcPts val="0"/>
@@ -3769,10 +3769,10 @@
             </a:lvl1pPr>
             <a:lvl2pPr marL="1005840" indent="-457200" algn="l">
               <a:lnSpc>
-                <a:spcPct val="125000"/>
+                <a:spcPct val="150000"/>
               </a:lnSpc>
               <a:spcBef>
-                <a:spcPts val="400"/>
+                <a:spcPts val="0"/>
               </a:spcBef>
               <a:spcAft>
                 <a:spcPts val="0"/>
@@ -3797,10 +3797,10 @@
             </a:lvl2pPr>
             <a:lvl3pPr marL="1463040" indent="-365760" algn="l">
               <a:lnSpc>
-                <a:spcPct val="125000"/>
+                <a:spcPct val="150000"/>
               </a:lnSpc>
               <a:spcBef>
-                <a:spcPts val="400"/>
+                <a:spcPts val="0"/>
               </a:spcBef>
               <a:spcAft>
                 <a:spcPts val="0"/>
@@ -3810,7 +3810,7 @@
               </a:buClr>
               <a:buSzPct val="90000"/>
               <a:buFont typeface="Arial" pitchFamily="2" charset="2"/>
-              <a:buChar char="–"/>
+              <a:buChar char="•"/>
               <a:defRPr lang="ko-KR" sz="2400" kern="0">
                 <a:solidFill>
                   <a:schemeClr val="tx1">
@@ -3880,7 +3880,7 @@
           <a:p>
             <a:r>
               <a:rPr lang="ko-KR" dirty="0"/>
-              <a:t>표·차트·넓은 그림</a:t>
+              <a:t>표, 차트, 넓은 그림</a:t>
             </a:r>
           </a:p>
         </p:txBody>
@@ -4139,10 +4139,10 @@
           <a:lstStyle>
             <a:lvl1pPr marL="502920" indent="-502920" algn="l">
               <a:lnSpc>
-                <a:spcPct val="125000"/>
+                <a:spcPct val="150000"/>
               </a:lnSpc>
               <a:spcBef>
-                <a:spcPts val="800"/>
+                <a:spcPts val="0"/>
               </a:spcBef>
               <a:spcAft>
                 <a:spcPts val="0"/>
@@ -4164,10 +4164,10 @@
             </a:lvl1pPr>
             <a:lvl2pPr marL="1005840" indent="-457200" algn="l">
               <a:lnSpc>
-                <a:spcPct val="125000"/>
+                <a:spcPct val="150000"/>
               </a:lnSpc>
               <a:spcBef>
-                <a:spcPts val="800"/>
+                <a:spcPts val="0"/>
               </a:spcBef>
               <a:spcAft>
                 <a:spcPts val="0"/>
@@ -4192,10 +4192,10 @@
             </a:lvl2pPr>
             <a:lvl3pPr marL="1463040" indent="-365760" algn="l">
               <a:lnSpc>
-                <a:spcPct val="125000"/>
+                <a:spcPct val="150000"/>
               </a:lnSpc>
               <a:spcBef>
-                <a:spcPts val="800"/>
+                <a:spcPts val="0"/>
               </a:spcBef>
               <a:spcAft>
                 <a:spcPts val="0"/>
@@ -4205,7 +4205,7 @@
               </a:buClr>
               <a:buSzPct val="90000"/>
               <a:buFont typeface="Arial" pitchFamily="2" charset="2"/>
-              <a:buChar char="–"/>
+              <a:buChar char="•"/>
               <a:defRPr lang="ko-KR" sz="2200" kern="0">
                 <a:solidFill>
                   <a:schemeClr val="tx1">
@@ -4317,10 +4317,10 @@
           <a:lstStyle>
             <a:lvl1pPr marL="502920" indent="-502920" algn="l">
               <a:lnSpc>
-                <a:spcPct val="125000"/>
+                <a:spcPct val="150000"/>
               </a:lnSpc>
               <a:spcBef>
-                <a:spcPts val="800"/>
+                <a:spcPts val="0"/>
               </a:spcBef>
               <a:spcAft>
                 <a:spcPts val="0"/>
@@ -4342,10 +4342,10 @@
             </a:lvl1pPr>
             <a:lvl2pPr marL="1005840" indent="-457200" algn="l">
               <a:lnSpc>
-                <a:spcPct val="125000"/>
+                <a:spcPct val="150000"/>
               </a:lnSpc>
               <a:spcBef>
-                <a:spcPts val="800"/>
+                <a:spcPts val="0"/>
               </a:spcBef>
               <a:spcAft>
                 <a:spcPts val="0"/>
@@ -4370,10 +4370,10 @@
             </a:lvl2pPr>
             <a:lvl3pPr marL="1463040" indent="-365760" algn="l">
               <a:lnSpc>
-                <a:spcPct val="125000"/>
+                <a:spcPct val="150000"/>
               </a:lnSpc>
               <a:spcBef>
-                <a:spcPts val="800"/>
+                <a:spcPts val="0"/>
               </a:spcBef>
               <a:spcAft>
                 <a:spcPts val="0"/>
@@ -4383,7 +4383,7 @@
               </a:buClr>
               <a:buSzPct val="90000"/>
               <a:buFont typeface="Arial" pitchFamily="2" charset="2"/>
-              <a:buChar char="–"/>
+              <a:buChar char="•"/>
               <a:defRPr lang="ko-KR" sz="2200" kern="0">
                 <a:solidFill>
                   <a:schemeClr val="tx1">
@@ -4595,16 +4595,16 @@
           </a:solidFill>
         </p:spPr>
         <p:txBody>
-          <a:bodyPr wrap="square" lIns="365760" tIns="137160" rIns="365760" bIns="137160" anchor="ctr" rtlCol="0">
+          <a:bodyPr wrap="square" lIns="365760" tIns="91440" rIns="365760" bIns="91440" anchor="ctr" rtlCol="0">
             <a:normAutofit/>
           </a:bodyPr>
           <a:lstStyle>
             <a:lvl1pPr marL="502920" indent="-502920" algn="l">
               <a:lnSpc>
-                <a:spcPct val="125000"/>
+                <a:spcPct val="150000"/>
               </a:lnSpc>
               <a:spcBef>
-                <a:spcPts val="400"/>
+                <a:spcPts val="0"/>
               </a:spcBef>
               <a:spcAft>
                 <a:spcPts val="0"/>
@@ -4626,10 +4626,10 @@
             </a:lvl1pPr>
             <a:lvl2pPr marL="1005840" indent="-457200" algn="l">
               <a:lnSpc>
-                <a:spcPct val="125000"/>
+                <a:spcPct val="150000"/>
               </a:lnSpc>
               <a:spcBef>
-                <a:spcPts val="400"/>
+                <a:spcPts val="0"/>
               </a:spcBef>
               <a:spcAft>
                 <a:spcPts val="0"/>
@@ -4654,10 +4654,10 @@
             </a:lvl2pPr>
             <a:lvl3pPr marL="1463040" indent="-365760" algn="l">
               <a:lnSpc>
-                <a:spcPct val="125000"/>
+                <a:spcPct val="150000"/>
               </a:lnSpc>
               <a:spcBef>
-                <a:spcPts val="400"/>
+                <a:spcPts val="0"/>
               </a:spcBef>
               <a:spcAft>
                 <a:spcPts val="0"/>
@@ -4667,7 +4667,7 @@
               </a:buClr>
               <a:buSzPct val="90000"/>
               <a:buFont typeface="Arial" pitchFamily="2" charset="2"/>
-              <a:buChar char="–"/>
+              <a:buChar char="•"/>
               <a:defRPr lang="ko-KR" sz="2400" kern="0">
                 <a:solidFill>
                   <a:schemeClr val="tx1">
@@ -5019,7 +5019,7 @@
                   <a:schemeClr val="bg1"/>
                 </a:solidFill>
               </a:rPr>
-              <a:t>Papers You Should Read  ·  DSBA Lab</a:t>
+              <a:t>Papers You Should Read  |  DSBA Lab</a:t>
             </a:r>
           </a:p>
         </p:txBody>
@@ -5169,10 +5169,10 @@
     <p:bodyStyle>
       <a:lvl1pPr marL="502920" indent="-502920" algn="l">
         <a:lnSpc>
-          <a:spcPct val="130000"/>
+          <a:spcPct val="150000"/>
         </a:lnSpc>
         <a:spcBef>
-          <a:spcPts val="600"/>
+          <a:spcPts val="0"/>
         </a:spcBef>
         <a:spcAft>
           <a:spcPts val="0"/>
@@ -5194,10 +5194,10 @@
       </a:lvl1pPr>
       <a:lvl2pPr marL="1005840" indent="-457200" algn="l">
         <a:lnSpc>
-          <a:spcPct val="130000"/>
+          <a:spcPct val="150000"/>
         </a:lnSpc>
         <a:spcBef>
-          <a:spcPts val="600"/>
+          <a:spcPts val="0"/>
         </a:spcBef>
         <a:spcAft>
           <a:spcPts val="0"/>
@@ -5222,10 +5222,10 @@
       </a:lvl2pPr>
       <a:lvl3pPr marL="1463040" indent="-365760" algn="l">
         <a:lnSpc>
-          <a:spcPct val="130000"/>
+          <a:spcPct val="150000"/>
         </a:lnSpc>
         <a:spcBef>
-          <a:spcPts val="600"/>
+          <a:spcPts val="0"/>
         </a:spcBef>
         <a:spcAft>
           <a:spcPts val="0"/>
@@ -5235,7 +5235,7 @@
         </a:buClr>
         <a:buSzPct val="90000"/>
         <a:buFont typeface="Arial" pitchFamily="2" charset="2"/>
-        <a:buChar char="–"/>
+        <a:buChar char="•"/>
         <a:defRPr lang="ko-KR" sz="2400" kern="0">
           <a:solidFill>
             <a:schemeClr val="tx1">
@@ -5509,7 +5509,7 @@
           <a:p>
             <a:pPr/>
             <a:r>
-              <a:t>숨김 가이드 슬라이드는 슬라이드 쇼·영상 녹화에 나오지 않음</a:t>
+              <a:t>숨김 가이드 슬라이드는 슬라이드 쇼, 영상 녹화에 나오지 않음</a:t>
             </a:r>
           </a:p>
         </p:txBody>
@@ -5909,7 +5909,7 @@
           <a:p>
             <a:pPr/>
             <a:r>
-              <a:t>표·차트 배치</a:t>
+              <a:t>표, 차트 배치</a:t>
             </a:r>
           </a:p>
         </p:txBody>
@@ -6727,7 +6727,7 @@
           <a:p>
             <a:pPr/>
             <a:r>
-              <a:t>도형·수식 구성</a:t>
+              <a:t>도형, 수식 구성</a:t>
             </a:r>
           </a:p>
         </p:txBody>
@@ -6788,7 +6788,7 @@
           <a:p>
             <a:pPr lvl="1"/>
             <a:r>
-              <a:t>flow·box·arrow·math 컴포넌트를 spec으로 배치</a:t>
+              <a:t>flow, box, arrow, math 컴포넌트를 spec으로 배치</a:t>
             </a:r>
           </a:p>
         </p:txBody>
@@ -7412,7 +7412,7 @@
         <mc:Fallback>
           <p:pic>
             <p:nvPicPr>
-              <p:cNvPr id="17" name="Picture 16" descr="tmp4w5o6rat.png"/>
+              <p:cNvPr id="17" name="Picture 16" descr="tmpcn18req3.png"/>
               <p:cNvPicPr>
                 <a:picLocks noChangeAspect="1"/>
               </p:cNvPicPr>
@@ -7561,6 +7561,9 @@
           <a:lstStyle/>
           <a:p>
             <a:pPr marL="457200" indent="-384048" algn="l">
+              <a:lnSpc>
+                <a:spcPct val="150000"/>
+              </a:lnSpc>
               <a:buClr>
                 <a:schemeClr val="accent1"/>
               </a:buClr>
@@ -7579,6 +7582,9 @@
           </a:p>
           <a:p>
             <a:pPr lvl="1" marL="914400" indent="-365760" algn="l">
+              <a:lnSpc>
+                <a:spcPct val="150000"/>
+              </a:lnSpc>
               <a:buClr>
                 <a:schemeClr val="accent1"/>
               </a:buClr>
@@ -7600,6 +7606,9 @@
           </a:p>
           <a:p>
             <a:pPr lvl="1" marL="914400" indent="-365760" algn="l">
+              <a:lnSpc>
+                <a:spcPct val="150000"/>
+              </a:lnSpc>
               <a:buClr>
                 <a:schemeClr val="accent1"/>
               </a:buClr>
@@ -7621,6 +7630,9 @@
           </a:p>
           <a:p>
             <a:pPr marL="457200" indent="-384048" algn="l">
+              <a:lnSpc>
+                <a:spcPct val="150000"/>
+              </a:lnSpc>
               <a:buClr>
                 <a:schemeClr val="accent1"/>
               </a:buClr>
@@ -7846,7 +7858,7 @@
           <a:p>
             <a:pPr/>
             <a:r>
-              <a:t>Papers You Should Read  ·  20XX QX</a:t>
+              <a:t>Papers You Should Read  |  20XX QX</a:t>
             </a:r>
           </a:p>
         </p:txBody>
@@ -7886,7 +7898,7 @@
           <a:p>
             <a:pPr/>
             <a:r>
-              <a:t>색상 체계 — Pantone 기반 팔레트 A</a:t>
+              <a:t>색상 체계: Pantone 기반 팔레트 A</a:t>
             </a:r>
           </a:p>
         </p:txBody>
@@ -7981,18 +7993,26 @@
           </a:bodyPr>
           <a:lstStyle/>
           <a:p>
-            <a:pPr algn="l"/>
+            <a:pPr algn="l">
+              <a:lnSpc>
+                <a:spcPct val="150000"/>
+              </a:lnSpc>
+            </a:pPr>
             <a:r>
               <a:rPr b="0" sz="1600">
                 <a:solidFill>
                   <a:schemeClr val="tx1"/>
                 </a:solidFill>
               </a:rPr>
-              <a:t>구조 · accent1</a:t>
-            </a:r>
-          </a:p>
-          <a:p>
-            <a:pPr algn="l"/>
+              <a:t>구조: accent1</a:t>
+            </a:r>
+          </a:p>
+          <a:p>
+            <a:pPr algn="l">
+              <a:lnSpc>
+                <a:spcPct val="150000"/>
+              </a:lnSpc>
+            </a:pPr>
             <a:r>
               <a:rPr b="0" sz="1600">
                 <a:solidFill>
@@ -8072,18 +8092,26 @@
           </a:bodyPr>
           <a:lstStyle/>
           <a:p>
-            <a:pPr algn="l"/>
+            <a:pPr algn="l">
+              <a:lnSpc>
+                <a:spcPct val="150000"/>
+              </a:lnSpc>
+            </a:pPr>
             <a:r>
               <a:rPr b="0" sz="1600">
                 <a:solidFill>
                   <a:schemeClr val="tx1"/>
                 </a:solidFill>
               </a:rPr>
-              <a:t>핵심 강조 · accent2</a:t>
-            </a:r>
-          </a:p>
-          <a:p>
-            <a:pPr algn="l"/>
+              <a:t>핵심 강조: accent2</a:t>
+            </a:r>
+          </a:p>
+          <a:p>
+            <a:pPr algn="l">
+              <a:lnSpc>
+                <a:spcPct val="150000"/>
+              </a:lnSpc>
+            </a:pPr>
             <a:r>
               <a:rPr b="0" sz="1600">
                 <a:solidFill>
@@ -8163,18 +8191,26 @@
           </a:bodyPr>
           <a:lstStyle/>
           <a:p>
-            <a:pPr algn="l"/>
+            <a:pPr algn="l">
+              <a:lnSpc>
+                <a:spcPct val="150000"/>
+              </a:lnSpc>
+            </a:pPr>
             <a:r>
               <a:rPr b="0" sz="1600">
                 <a:solidFill>
                   <a:schemeClr val="tx1"/>
                 </a:solidFill>
               </a:rPr>
-              <a:t>보조 · accent3</a:t>
-            </a:r>
-          </a:p>
-          <a:p>
-            <a:pPr algn="l"/>
+              <a:t>보조: accent3</a:t>
+            </a:r>
+          </a:p>
+          <a:p>
+            <a:pPr algn="l">
+              <a:lnSpc>
+                <a:spcPct val="150000"/>
+              </a:lnSpc>
+            </a:pPr>
             <a:r>
               <a:rPr b="0" sz="1600">
                 <a:solidFill>
@@ -8254,18 +8290,26 @@
           </a:bodyPr>
           <a:lstStyle/>
           <a:p>
-            <a:pPr algn="l"/>
+            <a:pPr algn="l">
+              <a:lnSpc>
+                <a:spcPct val="150000"/>
+              </a:lnSpc>
+            </a:pPr>
             <a:r>
               <a:rPr b="0" sz="1600">
                 <a:solidFill>
                   <a:schemeClr val="tx1"/>
                 </a:solidFill>
               </a:rPr>
-              <a:t>검증·정답 · accent4</a:t>
-            </a:r>
-          </a:p>
-          <a:p>
-            <a:pPr algn="l"/>
+              <a:t>검증, 정답: accent4</a:t>
+            </a:r>
+          </a:p>
+          <a:p>
+            <a:pPr algn="l">
+              <a:lnSpc>
+                <a:spcPct val="150000"/>
+              </a:lnSpc>
+            </a:pPr>
             <a:r>
               <a:rPr b="0" sz="1600">
                 <a:solidFill>
@@ -8345,18 +8389,26 @@
           </a:bodyPr>
           <a:lstStyle/>
           <a:p>
-            <a:pPr algn="l"/>
+            <a:pPr algn="l">
+              <a:lnSpc>
+                <a:spcPct val="150000"/>
+              </a:lnSpc>
+            </a:pPr>
             <a:r>
               <a:rPr b="0" sz="1600">
                 <a:solidFill>
                   <a:schemeClr val="tx1"/>
                 </a:solidFill>
               </a:rPr>
-              <a:t>낮은 우선 · accent5</a:t>
-            </a:r>
-          </a:p>
-          <a:p>
-            <a:pPr algn="l"/>
+              <a:t>낮은 우선: accent5</a:t>
+            </a:r>
+          </a:p>
+          <a:p>
+            <a:pPr algn="l">
+              <a:lnSpc>
+                <a:spcPct val="150000"/>
+              </a:lnSpc>
+            </a:pPr>
             <a:r>
               <a:rPr b="0" sz="1600">
                 <a:solidFill>
@@ -8436,18 +8488,26 @@
           </a:bodyPr>
           <a:lstStyle/>
           <a:p>
-            <a:pPr algn="l"/>
+            <a:pPr algn="l">
+              <a:lnSpc>
+                <a:spcPct val="150000"/>
+              </a:lnSpc>
+            </a:pPr>
             <a:r>
               <a:rPr b="0" sz="1600">
                 <a:solidFill>
                   <a:schemeClr val="tx1"/>
                 </a:solidFill>
               </a:rPr>
-              <a:t>중립 · accent6</a:t>
-            </a:r>
-          </a:p>
-          <a:p>
-            <a:pPr algn="l"/>
+              <a:t>중립: accent6</a:t>
+            </a:r>
+          </a:p>
+          <a:p>
+            <a:pPr algn="l">
+              <a:lnSpc>
+                <a:spcPct val="150000"/>
+              </a:lnSpc>
+            </a:pPr>
             <a:r>
               <a:rPr b="0" sz="1600">
                 <a:solidFill>
@@ -8481,7 +8541,11 @@
           </a:bodyPr>
           <a:lstStyle/>
           <a:p>
-            <a:pPr algn="l"/>
+            <a:pPr algn="l">
+              <a:lnSpc>
+                <a:spcPct val="150000"/>
+              </a:lnSpc>
+            </a:pPr>
             <a:r>
               <a:rPr b="0" sz="2200">
                 <a:solidFill>
@@ -8492,7 +8556,11 @@
             </a:r>
           </a:p>
           <a:p>
-            <a:pPr algn="l"/>
+            <a:pPr algn="l">
+              <a:lnSpc>
+                <a:spcPct val="150000"/>
+              </a:lnSpc>
+            </a:pPr>
             <a:r>
               <a:rPr b="0" sz="2200">
                 <a:solidFill>
@@ -8503,7 +8571,11 @@
             </a:r>
           </a:p>
           <a:p>
-            <a:pPr algn="l"/>
+            <a:pPr algn="l">
+              <a:lnSpc>
+                <a:spcPct val="150000"/>
+              </a:lnSpc>
+            </a:pPr>
             <a:r>
               <a:rPr b="0" sz="2200">
                 <a:solidFill>
@@ -8550,7 +8622,7 @@
           <a:p>
             <a:pPr/>
             <a:r>
-              <a:t>도형 규칙 — 같은 종류는 같은 색, 역할이 있을 때만 다른 색</a:t>
+              <a:t>도형 규칙: 같은 종류는 같은 색, 역할이 있을 때만 다른 색</a:t>
             </a:r>
           </a:p>
         </p:txBody>
@@ -8572,7 +8644,7 @@
           <a:p>
             <a:pPr/>
             <a:r>
-              <a:t>도형은 색이 아니라 종류(kind)로 고름. 한 슬라이드의 강조(key·emph)는 1~2개까지</a:t>
+              <a:t>도형은 색이 아니라 종류(kind)로 고름. 한 슬라이드의 강조(key, emph)는 1~2개까지</a:t>
             </a:r>
           </a:p>
         </p:txBody>
@@ -8656,7 +8728,11 @@
           </a:bodyPr>
           <a:lstStyle/>
           <a:p>
-            <a:pPr algn="l"/>
+            <a:pPr algn="l">
+              <a:lnSpc>
+                <a:spcPct val="150000"/>
+              </a:lnSpc>
+            </a:pPr>
             <a:r>
               <a:rPr b="0" sz="1600">
                 <a:solidFill>
@@ -8666,7 +8742,7 @@
                   </a:schemeClr>
                 </a:solidFill>
               </a:rPr>
-              <a:t>일반 모듈·단계</a:t>
+              <a:t>일반 모듈, 단계</a:t>
             </a:r>
           </a:p>
         </p:txBody>
@@ -8747,7 +8823,11 @@
           </a:bodyPr>
           <a:lstStyle/>
           <a:p>
-            <a:pPr algn="l"/>
+            <a:pPr algn="l">
+              <a:lnSpc>
+                <a:spcPct val="150000"/>
+              </a:lnSpc>
+            </a:pPr>
             <a:r>
               <a:rPr b="0" sz="1600">
                 <a:solidFill>
@@ -8840,7 +8920,11 @@
           </a:bodyPr>
           <a:lstStyle/>
           <a:p>
-            <a:pPr algn="l"/>
+            <a:pPr algn="l">
+              <a:lnSpc>
+                <a:spcPct val="150000"/>
+              </a:lnSpc>
+            </a:pPr>
             <a:r>
               <a:rPr b="0" sz="1600">
                 <a:solidFill>
@@ -8850,7 +8934,7 @@
                   </a:schemeClr>
                 </a:solidFill>
               </a:rPr>
-              <a:t>문제점·한계·핵심 주장</a:t>
+              <a:t>문제점, 한계, 핵심 주장</a:t>
             </a:r>
           </a:p>
         </p:txBody>
@@ -8934,7 +9018,11 @@
           </a:bodyPr>
           <a:lstStyle/>
           <a:p>
-            <a:pPr algn="l"/>
+            <a:pPr algn="l">
+              <a:lnSpc>
+                <a:spcPct val="150000"/>
+              </a:lnSpc>
+            </a:pPr>
             <a:r>
               <a:rPr b="0" sz="1600">
                 <a:solidFill>
@@ -8944,7 +9032,7 @@
                   </a:schemeClr>
                 </a:solidFill>
               </a:rPr>
-              <a:t>검증 통과·정답</a:t>
+              <a:t>검증 통과, 정답</a:t>
             </a:r>
           </a:p>
         </p:txBody>
@@ -9031,7 +9119,11 @@
           </a:bodyPr>
           <a:lstStyle/>
           <a:p>
-            <a:pPr algn="l"/>
+            <a:pPr algn="l">
+              <a:lnSpc>
+                <a:spcPct val="150000"/>
+              </a:lnSpc>
+            </a:pPr>
             <a:r>
               <a:rPr b="0" sz="1600">
                 <a:solidFill>
@@ -9041,7 +9133,7 @@
                   </a:schemeClr>
                 </a:solidFill>
               </a:rPr>
-              <a:t>참고·낮은 우선순위</a:t>
+              <a:t>참고, 낮은 우선순위</a:t>
             </a:r>
           </a:p>
         </p:txBody>
@@ -9125,7 +9217,11 @@
           </a:bodyPr>
           <a:lstStyle/>
           <a:p>
-            <a:pPr algn="l"/>
+            <a:pPr algn="l">
+              <a:lnSpc>
+                <a:spcPct val="150000"/>
+              </a:lnSpc>
+            </a:pPr>
             <a:r>
               <a:rPr b="0" sz="1600">
                 <a:solidFill>
@@ -9135,7 +9231,7 @@
                   </a:schemeClr>
                 </a:solidFill>
               </a:rPr>
-              <a:t>baseline·비활성</a:t>
+              <a:t>baseline, 비활성</a:t>
             </a:r>
           </a:p>
         </p:txBody>
@@ -9221,7 +9317,11 @@
           </a:bodyPr>
           <a:lstStyle/>
           <a:p>
-            <a:pPr algn="l"/>
+            <a:pPr algn="l">
+              <a:lnSpc>
+                <a:spcPct val="150000"/>
+              </a:lnSpc>
+            </a:pPr>
             <a:r>
               <a:rPr b="0" sz="1600">
                 <a:solidFill>
@@ -9231,7 +9331,7 @@
                   </a:schemeClr>
                 </a:solidFill>
               </a:rPr>
-              <a:t>묶음 틀·컨테이너</a:t>
+              <a:t>묶음 틀, 컨테이너</a:t>
             </a:r>
           </a:p>
         </p:txBody>
@@ -9376,7 +9476,11 @@
           </a:bodyPr>
           <a:lstStyle/>
           <a:p>
-            <a:pPr algn="l"/>
+            <a:pPr algn="l">
+              <a:lnSpc>
+                <a:spcPct val="150000"/>
+              </a:lnSpc>
+            </a:pPr>
             <a:r>
               <a:rPr b="0" sz="1600">
                 <a:solidFill>
@@ -9386,7 +9490,7 @@
                   </a:schemeClr>
                 </a:solidFill>
               </a:rPr>
-              <a:t>화살표 default·key / 그림 위 강조 틀</a:t>
+              <a:t>화살표 default, key / 그림 위 강조 틀</a:t>
             </a:r>
           </a:p>
         </p:txBody>
@@ -9413,7 +9517,11 @@
           </a:bodyPr>
           <a:lstStyle/>
           <a:p>
-            <a:pPr algn="l"/>
+            <a:pPr algn="l">
+              <a:lnSpc>
+                <a:spcPct val="150000"/>
+              </a:lnSpc>
+            </a:pPr>
             <a:r>
               <a:rPr b="0" sz="2000">
                 <a:solidFill>
@@ -9488,14 +9596,18 @@
             </a:r>
           </a:p>
           <a:p>
-            <a:pPr algn="l"/>
+            <a:pPr algn="l">
+              <a:lnSpc>
+                <a:spcPct val="150000"/>
+              </a:lnSpc>
+            </a:pPr>
             <a:r>
               <a:rPr b="0" sz="2000">
                 <a:solidFill>
                   <a:schemeClr val="tx1"/>
                 </a:solidFill>
               </a:rPr>
-              <a:t>차트·표: Ours = accent2, baseline = accent6, 나머지 = accent3 → accent1 순서</a:t>
+              <a:t>차트, 표: Ours = accent2, baseline = accent6, 나머지 = accent3 → accent1 순서</a:t>
             </a:r>
           </a:p>
         </p:txBody>
@@ -9557,61 +9669,61 @@
           <a:p>
             <a:pPr/>
             <a:r>
-              <a:t>Title — 표지 (논문 제목, 인용, 발표자, 학회 로고)</a:t>
+              <a:t>Title: 표지 (논문 제목, 인용, 발표자, 학회 로고)</a:t>
             </a:r>
           </a:p>
           <a:p>
             <a:pPr/>
             <a:r>
-              <a:t>Contents — 목차 겸 섹션 구분, 현재 섹션만 강조</a:t>
+              <a:t>Contents: 목차 겸 섹션 구분, 현재 섹션만 강조</a:t>
             </a:r>
           </a:p>
           <a:p>
             <a:pPr/>
             <a:r>
-              <a:t>A_FigureFull_Band — 그림 1개 전면 + 하단 밴드</a:t>
+              <a:t>A_FigureFull_Band: 그림 1개 전면 + 하단 밴드</a:t>
             </a:r>
           </a:p>
           <a:p>
             <a:pPr/>
             <a:r>
-              <a:t>B_FigureTwo_Band — 그림 2개 비교 + 하단 밴드</a:t>
+              <a:t>B_FigureTwo_Band: 그림 2개 비교 + 하단 밴드</a:t>
             </a:r>
           </a:p>
           <a:p>
             <a:pPr/>
             <a:r>
-              <a:t>C_FigureExplain_Band — 좌 그림 + 우 해설 + 하단 밴드</a:t>
+              <a:t>C_FigureExplain_Band: 좌 그림 + 우 해설 + 하단 밴드</a:t>
             </a:r>
           </a:p>
           <a:p>
             <a:pPr/>
             <a:r>
-              <a:t>D_TopBand_Wide — 상단 밴드 + 넓은 표·차트</a:t>
+              <a:t>D_TopBand_Wide: 상단 밴드 + 넓은 표, 차트</a:t>
             </a:r>
           </a:p>
           <a:p>
             <a:pPr/>
             <a:r>
-              <a:t>E_TwoColumn — 2단 카드 (비교·결론)</a:t>
+              <a:t>E_TwoColumn: 2단 카드 (비교, 결론)</a:t>
             </a:r>
           </a:p>
           <a:p>
             <a:pPr/>
             <a:r>
-              <a:t>F_Diagram_Band — 도형·수식 자유 영역 + 하단 밴드</a:t>
+              <a:t>F_Diagram_Band: 도형, 수식 자유 영역 + 하단 밴드</a:t>
             </a:r>
           </a:p>
           <a:p>
             <a:pPr/>
             <a:r>
-              <a:t>G_TitleOnly — 제목만 (자유 구성, 부록) / H_Statement — 핵심 질문·한 문장 요약</a:t>
+              <a:t>G_TitleOnly: 제목만 (자유 구성, 부록) / H_Statement: 핵심 질문, 한 문장 요약</a:t>
             </a:r>
           </a:p>
           <a:p>
             <a:pPr/>
             <a:r>
-              <a:t>Closing — 마무리 / Guide — 숨김 가이드 전용</a:t>
+              <a:t>Closing: 마무리 / Guide: 숨김 가이드 전용</a:t>
             </a:r>
           </a:p>
         </p:txBody>
@@ -9681,7 +9793,7 @@
               <a:p>
                 <a:pPr/>
                 <a:r>
-                  <a:t>한 장에 핵심 메시지 하나: 주장은 제목이 아니라 밴드 1단에, 근거·수치는 2단에 (32pt 기준 한 줄 40자, 3~4줄)</a:t>
+                  <a:t>한 장에 핵심 메시지 하나: 주장은 제목이 아니라 밴드 1단에, 근거, 수치는 2단에 (32pt 기준 한 줄 40자, 3~4줄)</a:t>
                 </a:r>
               </a:p>
               <a:p>
@@ -9784,7 +9896,7 @@
               <a:p>
                 <a:pPr/>
                 <a:r>
-                  <a:t>한 장에 핵심 메시지 하나: 주장은 제목이 아니라 밴드 1단에, 근거·수치는 2단에 (32pt 기준 한 줄 40자, 3~4줄)</a:t>
+                  <a:t>한 장에 핵심 메시지 하나: 주장은 제목이 아니라 밴드 1단에, 근거, 수치는 2단에 (32pt 기준 한 줄 40자, 3~4줄)</a:t>
                 </a:r>
               </a:p>
               <a:p>
@@ -9915,7 +10027,7 @@
           <a:p>
             <a:pPr/>
             <a:r>
-              <a:t>프롬프트 요소: 목적과 개념 · 대상과 캐릭터 · 표정과 행동 · 구도와 비율 · 팔레트와 배경</a:t>
+              <a:t>프롬프트 요소: 목적과 개념, 대상과 캐릭터, 표정과 행동, 구도와 비율, 팔레트와 배경</a:t>
             </a:r>
           </a:p>
           <a:p>

</xml_diff>